<commit_message>
Mostra que a perda da área de Pedro Henrique é desproporcional, não só grande
O card do slide 3 (portal e PPTX) mostrava só o volume absoluto de gap
(63 OS, 26% da perda do Ceará). Acrescenta o % da própria capacidade
perdida (27,5% vs 19,2% da média do Ceará) e o OS/dia por técnico
(2,65, o mais baixo entre todas as GAs), para provar que a área tem
desempenho desproporcional ao tamanho — não é grande só porque tem
mais gente.

Co-Authored-By: Claude Fable 5 <noreply@anthropic.com>
</commit_message>
<xml_diff>
--- a/outputs/3ps/3Ps_Ceara_Executivo.pptx
+++ b/outputs/3ps/3Ps_Ceara_Executivo.pptx
@@ -9314,8 +9314,8 @@
         </p:nvSpPr>
         <p:spPr>
           <a:xfrm>
-            <a:off x="742950" y="3543300"/>
-            <a:ext cx="3886200" cy="1447800"/>
+            <a:off x="742950" y="3486150"/>
+            <a:ext cx="3886200" cy="1600200"/>
           </a:xfrm>
           <a:prstGeom prst="rect">
             <a:avLst/>
@@ -9358,8 +9358,8 @@
         </p:nvSpPr>
         <p:spPr>
           <a:xfrm>
-            <a:off x="742950" y="3543300"/>
-            <a:ext cx="47625" cy="1447800"/>
+            <a:off x="742950" y="3486150"/>
+            <a:ext cx="47625" cy="1600200"/>
           </a:xfrm>
           <a:prstGeom prst="rect">
             <a:avLst/>
@@ -9402,7 +9402,7 @@
         </p:nvSpPr>
         <p:spPr>
           <a:xfrm>
-            <a:off x="895350" y="3676650"/>
+            <a:off x="895350" y="3600450"/>
             <a:ext cx="762000" cy="285750"/>
           </a:xfrm>
           <a:prstGeom prst="rect">
@@ -9441,8 +9441,8 @@
         </p:nvSpPr>
         <p:spPr>
           <a:xfrm>
-            <a:off x="895350" y="3981450"/>
-            <a:ext cx="3581400" cy="952500"/>
+            <a:off x="895350" y="3905250"/>
+            <a:ext cx="3581400" cy="1104900"/>
           </a:xfrm>
           <a:prstGeom prst="rect">
             <a:avLst/>
@@ -9461,13 +9461,13 @@
               </a:lnSpc>
             </a:pPr>
             <a:r>
-              <a:rPr sz="1150" b="0">
+              <a:rPr sz="1050" b="0">
                 <a:solidFill>
                   <a:srgbClr val="4A5B52"/>
                 </a:solidFill>
                 <a:latin typeface="Aptos"/>
               </a:rPr>
-              <a:t>de toda a perda do Ceará está numa única área: a de Pedro Henrique, com 21 dos 22 técnicos abaixo da meta. A mesma área lidera as visitas improdutivas (82 de 328). É por ela que a recuperação começa.</a:t>
+              <a:t>de toda a perda do Ceará está numa única área — que também perde 27% da própria capacidade esperada (167 de 230 OS possíveis), quase 50% pior que a média do Ceará (19%). 21 dos 22 técnicos estão abaixo da meta; mesma área lidera as visitas improdutivas (82 de 328).</a:t>
             </a:r>
           </a:p>
         </p:txBody>

</xml_diff>